<commit_message>
docs(pmc): emblema e nome em imagem no cabeçalho, objetivos do projeto e siglas por extenso
Co-Authored-By: Claude Opus 5.5 <noreply@anthropic.com>
</commit_message>
<xml_diff>
--- a/bmc/pmc/PM_Canvas_ObraNexo.pptx
+++ b/bmc/pmc/PM_Canvas_ObraNexo.pptx
@@ -12534,67 +12534,32 @@
           </p:txBody>
         </p:sp>
       </p:grpSp>
-      <p:sp>
-        <p:nvSpPr>
-          <p:cNvPr id="91" name="Google Shape;116;p13"/>
-          <p:cNvSpPr/>
+      <p:pic>
+        <p:nvPicPr>
+          <p:cNvPr id="900" name="Logotipo ObraNexo" descr="ObraNexo"/>
+          <p:cNvPicPr preferRelativeResize="0"/>
           <p:nvPr/>
-        </p:nvSpPr>
+        </p:nvPicPr>
+        <p:blipFill>
+          <a:blip r:embed="rId99"/>
+          <a:stretch>
+            <a:fillRect/>
+          </a:stretch>
+        </p:blipFill>
         <p:spPr>
           <a:xfrm>
-            <a:off x="3337200" y="389880"/>
-            <a:ext cx="11912040" cy="594000"/>
+            <a:off x="7459079" y="359640"/>
+            <a:ext cx="3369842" cy="586440"/>
           </a:xfrm>
           <a:prstGeom prst="rect">
             <a:avLst/>
           </a:prstGeom>
           <a:noFill/>
-          <a:ln w="0">
+          <a:ln>
             <a:noFill/>
           </a:ln>
         </p:spPr>
-        <p:style>
-          <a:lnRef idx="0"/>
-          <a:fillRef idx="0"/>
-          <a:effectRef idx="0"/>
-          <a:fontRef idx="minor"/>
-        </p:style>
-        <p:txBody>
-          <a:bodyPr lIns="0" tIns="0" rIns="0" bIns="0" anchor="t">
-            <a:spAutoFit/>
-          </a:bodyPr>
-          <a:p>
-            <a:pPr algn="ctr">
-              <a:lnSpc>
-                <a:spcPct val="130000"/>
-              </a:lnSpc>
-              <a:tabLst>
-                <a:tab pos="0" algn="l"/>
-              </a:tabLst>
-            </a:pPr>
-            <a:r>
-              <a:rPr lang="en-US" sz="3000" b="1" u="none" strike="noStrike">
-                <a:solidFill>
-                  <a:srgbClr val="000000"/>
-                </a:solidFill>
-                <a:effectLst/>
-                <a:uFillTx/>
-                <a:latin typeface="Arial"/>
-                <a:ea typeface="Arial"/>
-              </a:rPr>
-              <a:t>OBRANEXO</a:t>
-            </a:r>
-            <a:endParaRPr lang="pt-BR" sz="3000" b="0" u="none" strike="noStrike">
-              <a:solidFill>
-                <a:srgbClr val="FFFFFF"/>
-              </a:solidFill>
-              <a:effectLst/>
-              <a:uFillTx/>
-              <a:latin typeface="Arial"/>
-            </a:endParaRPr>
-          </a:p>
-        </p:txBody>
-      </p:sp>
+      </p:pic>
       <p:sp>
         <p:nvSpPr>
           <p:cNvPr id="92" name="Google Shape;117;p13"/>
@@ -12738,7 +12703,7 @@
                 <a:latin typeface="Arial"/>
                 <a:ea typeface="Arial"/>
               </a:rPr>
-              <a:t>Sem analista, a PME não confere o edital em 8 dias úteis</a:t>
+              <a:t>Sem analista, a pequena empresa não confere o edital em 8 dias úteis</a:t>
             </a:r>
             <a:endParaRPr lang="pt-BR" sz="1500" b="0" u="none" strike="noStrike">
               <a:solidFill>
@@ -13678,7 +13643,7 @@
                 <a:latin typeface="Arial"/>
                 <a:ea typeface="Arial"/>
               </a:rPr>
-              <a:t>Demonstrar no hackathon regional (24/10/2026) e consolidar na etapa nacional (28/11/2026) um MVP que, com dados reais do PNCP, vá do catálogo do fornecedor ao dossiê comercial, com 100% das conclusões apoiadas em evidência.</a:t>
+              <a:t>Permitir que fornecedores de material elétrico encontrem e avaliem, com evidência, pregões do PNCP: em 36 meses, chegar a 250 clientes, ampliar a presença de micro e pequenas empresas nas licitações e reduzir itens desertos.</a:t>
             </a:r>
             <a:endParaRPr lang="pt-BR" sz="1500" b="0" u="none" strike="noStrike">
               <a:solidFill>
@@ -14121,7 +14086,7 @@
                 <a:latin typeface="Arial"/>
                 <a:ea typeface="Arial"/>
               </a:rPr>
-              <a:t>MPE: 45% dos itens elétricos são exclusivos para ME/EPP; ganhar contrato acelera o crescimento</a:t>
+              <a:t>Micro e pequenas empresas: 45% dos itens elétricos são exclusivos para elas</a:t>
             </a:r>
             <a:endParaRPr lang="pt-BR" sz="1500" b="0" u="none" strike="noStrike">
               <a:solidFill>
@@ -14179,7 +14144,7 @@
         <p:spPr>
           <a:xfrm>
             <a:off x="480960" y="359640"/>
-            <a:ext cx="2447640" cy="586440"/>
+            <a:ext cx="586440" cy="586440"/>
           </a:xfrm>
           <a:prstGeom prst="rect">
             <a:avLst/>

</xml_diff>